<commit_message>
ML midterm deck: new speaker notes from one shared script, fix slide 11 count
- src/talk_content.json is now the single source of the spoken script and
  study notes; build_deck.js reads speaker notes from it and
  src/build_talk.py writes TRANSCRIPT.md (and, optionally, the mobile study
  viewer from src/study_viewer.html).
- Slide 11 said 16 models beat the baseline; it now reads 14, computed
  from results/q2_metrics.json.
- Images get alt text instead of absolute local file paths.
- PDF: only page 11 was re-rendered (Liberation Sans, Arial-metric) and
  spliced in; the other 13 pages keep the original Arial render.
- pptx validate.py passes; notes match talk_content.json on all 14 slides.

Co-Authored-By: Claude Opus 5.5 <noreply@anthropic.com>
Claude-Session: https://claude.ai/code/session_01SizuVJfQhxREw1pyh2WW9i
</commit_message>
<xml_diff>
--- a/ML/MidTerm/presentation/midterm_presentation.pptx
+++ b/ML/MidTerm/presentation/midterm_presentation.pptx
@@ -120,13 +120,13 @@
   <p:extLst>
     <p:ext uri="{521415D9-36F7-43E2-AB2F-B90AF26B5E84}">
       <p14:sectionLst xmlns:p14="http://schemas.microsoft.com/office/powerpoint/2010/main">
-        <p14:section name="Mở đầu" id="{fea85a70-7a24-0483-a429-d7fb2b647ad3}">
+        <p14:section name="Mở đầu" id="{94ebbb47-9d04-da12-7341-a44b16edc5ca}">
           <p14:sldIdLst>
             <p14:sldId id="256"/>
             <p14:sldId id="257"/>
           </p14:sldIdLst>
         </p14:section>
-        <p14:section name="Câu 1" id="{1404695e-347a-033c-430a-568c0afa4060}">
+        <p14:section name="Câu 1" id="{fc5aece1-70a3-6463-ef21-1c9d9bd7b74f}">
           <p14:sldIdLst>
             <p14:sldId id="258"/>
             <p14:sldId id="259"/>
@@ -135,7 +135,7 @@
             <p14:sldId id="262"/>
           </p14:sldIdLst>
         </p14:section>
-        <p14:section name="Câu 2" id="{ce4722b9-a38b-5930-7d1e-469267311f20}">
+        <p14:section name="Câu 2" id="{b3fa28b6-a386-8b32-f6af-8c789898364b}">
           <p14:sldIdLst>
             <p14:sldId id="263"/>
             <p14:sldId id="264"/>
@@ -144,12 +144,12 @@
             <p14:sldId id="267"/>
           </p14:sldIdLst>
         </p14:section>
-        <p14:section name="Overfitting" id="{56fdecfc-c8fd-0cc1-8589-031c6c992300}">
+        <p14:section name="Overfitting" id="{ae99d017-e920-3199-1435-cbafcfbc532f}">
           <p14:sldIdLst>
             <p14:sldId id="268"/>
           </p14:sldIdLst>
         </p14:section>
-        <p14:section name="Kết luận" id="{da46ca7f-5c76-ac47-ffbd-e292bf578002}">
+        <p14:section name="Kết luận" id="{0a9b51ab-ef25-8d76-91a4-7a7621cfcbe3}">
           <p14:sldIdLst>
             <p14:sldId id="269"/>
           </p14:sldIdLst>
@@ -558,7 +558,7 @@
           <a:p>
             <a:r>
               <a:rPr lang="en-US" dirty="0"/>
-              <a:t>Kính thưa thầy và các bạn. Nhóm em gồm ba thành viên xin trình bày báo cáo giữa kỳ môn Introduction to Machine Learning. Bài gồm hai câu: câu một tự cài đặt hồi quy tuyến tính và logistic bằng Gradient Descent; câu hai so sánh các bộ phân loại trên bộ credit-g của OpenML. Phần trình bày khoảng mười phút.</a:t>
+              <a:t>Kính thưa thầy và các bạn. Nhóm em xin trình bày báo cáo giữa kỳ môn Introduction to Machine Learning, đề tài Hồi quy và Phân loại. Câu một tự cài đặt hồi quy tuyến tính và logistic bằng Gradient Descent. Câu hai so sánh 14 bộ phân loại trên bộ dữ liệu credit-g của OpenML.</a:t>
             </a:r>
             <a:endParaRPr lang="en-US" dirty="0"/>
           </a:p>
@@ -646,7 +646,7 @@
           <a:p>
             <a:r>
               <a:rPr lang="en-US" dirty="0"/>
-              <a:t>Nhóm so sánh mười bốn mô hình cùng một baseline trên cùng bộ fold. Ba kernel SVM là ba biến thể của một họ, không phải ba họ thuật toán. MLP dẫn đầu với macro F1 không phẩy sáu chín sáu, Bernoulli NB bám sát không phẩy sáu chín bốn, polynomial SVM không phẩy sáu tám sáu. Nhưng độ lệch chuẩn giữa các fold khoảng không phẩy không sáu, lớn hơn khoảng cách hai mô hình đầu, nên nhóm không tuyên bố MLP vượt trội. Điểm CV đã dùng để chọn tham số nên không phải đánh giá độc lập.</a:t>
+              <a:t>Nhóm so sánh 14 mô hình và một baseline trên cùng bộ fold, từ mô hình tuyến tính, kNN, Naive Bayes, cây, SVM, MLP đến ensemble; ba kernel SVM chỉ là ba biến thể của một họ. MLP dẫn đầu với macro F1 0.696, Bernoulli NB 0.694. Nhưng độ lệch chuẩn giữa các fold khoảng 0.06, lớn hơn nhiều khoảng cách 0.002, nên nhóm không kết luận MLP vượt trội. kNN chọn k bằng 1 và khớp hoàn hảo trên train, một dấu hiệu overfitting. Điểm CV đã dùng để chọn tham số, nên không phải đánh giá độc lập.</a:t>
             </a:r>
             <a:endParaRPr lang="en-US" dirty="0"/>
           </a:p>
@@ -734,7 +734,7 @@
           <a:p>
             <a:r>
               <a:rPr lang="en-US" dirty="0"/>
-              <a:t>Đây là kết quả trên hai trăm hồ sơ test chưa từng dùng để chọn mô hình. MLP có accuracy không phẩy bảy chín, macro F1 không phẩy bảy ba không, AUC không phẩy tám một ba. Đáng chú ý: hồi quy logistic tự cài đặt ở câu một đạt macro F1 không phẩy bảy ba không một, gần như bằng MLP. Trong bài toán nhỏ này, mô hình phức tạp hơn không mang lại lợi ích rõ rệt. Mọi mô hình học đều vượt baseline, nhưng chênh lệch chỉ vài phần nghìn. Em mời bạn Tâm trình bày phần overfitting.</a:t>
+              <a:t>Đánh giá độc lập là 200 hồ sơ test. MLP đạt accuracy 0.79, macro F1 0.73, AUC 0.81. Đáng chú ý, logistic tự cài đặt từ câu một cũng đạt macro F1 0.730, gần như bằng MLP: trên một bảng dữ liệu nhỏ, mô hình phức tạp hơn không mang lại lợi ích rõ ràng. Cả 14 mô hình đều vượt baseline về macro F1, nhưng nhóm dẫn đầu chỉ chênh nhau vài phần nghìn, nên không nên đọc bảng này như bảng xếp hạng. Em xin mời bạn Tâm.</a:t>
             </a:r>
             <a:endParaRPr lang="en-US" dirty="0"/>
           </a:p>
@@ -822,7 +822,7 @@
           <a:p>
             <a:r>
               <a:rPr lang="en-US" dirty="0"/>
-              <a:t>Bức tranh này là bài học chính của câu hai. MLP đúng một trăm năm mươi tám trên hai trăm, nghe rất tốt. Nhưng trong sáu mươi hồ sơ thực sự xấu, mô hình bỏ sót hai mươi tám, tức recall lớp bad chỉ không phẩy năm ba ba. Đây là cái bẫy của dữ liệu mất cân bằng: lớp đa số kéo accuracy lên trong khi lớp cần phát hiện bị bỏ qua. Nếu là bài toán tín dụng thật, bỏ sót hồ sơ xấu thường tốn kém hơn báo nhầm. Nhóm không hạ ngưỡng sau khi xem test, vì làm vậy là dùng test để tinh chỉnh.</a:t>
+              <a:t>Đây là bài học chính của câu hai. Ma trận nhầm lẫn có hàng là nhãn thật, cột là dự đoán. MLP đúng 158 trên 200, nhưng trong 60 hồ sơ xấu, mô hình bỏ sót 28, nên recall lớp bad chỉ 0.533. Lớp đa số đã kéo accuracy lên. Gaussian NB thì ngược lại: recall bad 0.65 nhưng precision chỉ 0.51. Chọn bên nào là quyết định nghiệp vụ, tùy chi phí bỏ sót so với báo nhầm. Muốn hạ ngưỡng thì phải chọn trên validation; hạ sau khi xem test là dùng test để tinh chỉnh.</a:t>
             </a:r>
             <a:endParaRPr lang="en-US" dirty="0"/>
           </a:p>
@@ -910,7 +910,7 @@
           <a:p>
             <a:r>
               <a:rPr lang="en-US" dirty="0"/>
-              <a:t>Biểu đồ bên trái tách riêng ảnh hưởng của độ sâu cây: độ sâu tăng thì điểm train leo lên một, nhưng validation chỉ tăng đến khoảng độ sâu sáu rồi giảm. Cây không giới hạn đạt một phẩy không trên train nhưng chỉ không phẩy sáu một bốn trên validation. Giới hạn độ sâu sáu và tối thiểu năm mẫu mỗi lá, khoảng cách thu hẹp từ không phẩy ba tám sáu xuống không phẩy một hai một, điểm validation tăng. Nhưng random forest sau khi chọn tham số vẫn còn khoảng cách không phẩy ba hai bốn. Ensemble giảm phương sai nhưng không miễn nhiễm với việc ghi nhớ dữ liệu.</a:t>
+              <a:t>Overfitting là khi mô hình học thuộc cả nhiễu của train, nên gặp dữ liệu mới thì kém; nhóm đo nó bằng khoảng cách train trừ validation. Ở biểu đồ trái, tăng độ sâu thì điểm train leo lên 1, còn validation chỉ tăng đến độ sâu khoảng 6 rồi giảm. Cây không giới hạn đạt 1.00 trên train nhưng 0.614 trên validation. Giới hạn độ sâu 6 và tối thiểu 5 mẫu mỗi lá, khoảng cách giảm từ 0.386 xuống 0.121. Nhưng random forest vẫn còn 0.324: ensemble giảm phương sai, không tự hết overfitting. Biện pháp chung là giới hạn độ phức tạp, chọn bằng validation và giữ test riêng.</a:t>
             </a:r>
             <a:endParaRPr lang="en-US" dirty="0"/>
           </a:p>
@@ -998,7 +998,7 @@
           <a:p>
             <a:r>
               <a:rPr lang="en-US" dirty="0"/>
-              <a:t>Tóm lại, câu một cho thấy hai mô hình tự cài đặt học đúng: gradient khớp kiểm tra sai phân, sai số xấp xỉ mức nhiễu. Câu hai cho thấy trên dữ liệu nhỏ và mất cân bằng, mô hình phức tạp nhất không vượt trội rõ rệt, và accuracy có thể che mất lỗi ở lớp thiểu số. Hạn chế: một bộ dữ liệu, một lần chia test, lưới tham số nhỏ; logistic và MLP đều chạm ngân sách vòng lặp nên chưa hội tụ; không có kiểm định thống kê. Em xin kết thúc và cảm ơn thầy, các bạn.</a:t>
+              <a:t>Tóm lại, câu một cho thấy hai mô hình tự cài đặt học đúng: gradient khớp kiểm tra sai phân, sai số xấp xỉ mức nhiễu. Câu hai cho thấy trên dữ liệu nhỏ và mất cân bằng, mô hình phức tạp nhất không vượt trội rõ rệt, và accuracy có thể che lỗi ở lớp thiểu số. Hạn chế: một bộ dữ liệu, một lần chia test, lưới tham số nhỏ; logistic và MLP chưa hội tụ hoàn toàn; và chưa có kiểm định thống kê. Nhóm em xin cảm ơn thầy và các bạn đã lắng nghe.</a:t>
             </a:r>
             <a:endParaRPr lang="en-US" dirty="0"/>
           </a:p>
@@ -1086,7 +1086,7 @@
           <a:p>
             <a:r>
               <a:rPr lang="en-US" dirty="0"/>
-              <a:t>Bài chia ba phần. Em trình bày câu một: tự cài đặt hai mô hình hồi quy, dẫn xuất gradient và đánh giá. Bạn Thành trình bày câu hai: dữ liệu credit-g, quy trình chống rò rỉ và so sánh mười bốn mô hình cùng baseline. Bạn Tâm trình bày overfitting và kết luận. Câu hỏi xuyên suốt: mô hình học được gì, và làm sao biết nó tổng quát hóa?</a:t>
+              <a:t>Bài gồm ba phần. Em trình bày câu một: mô hình, hàm mất mát, gradient và kết quả. Bạn Thành trình bày dữ liệu, quy trình và cách chọn mô hình ở câu hai. Bạn Tâm trình bày cách đọc kết quả, overfitting và kết luận. Câu hỏi xuyên suốt là: mô hình học được gì, và làm sao biết nó tổng quát hóa sang dữ liệu mới?</a:t>
             </a:r>
             <a:endParaRPr lang="en-US" dirty="0"/>
           </a:p>
@@ -1174,7 +1174,7 @@
           <a:p>
             <a:r>
               <a:rPr lang="en-US" dirty="0"/>
-              <a:t>Hồi quy tuyến tính dự đoán một số thực bằng tổng có trọng số của các đặc trưng cộng hệ số chặn. Vì đầu ra là số thực nên đây là bài toán hồi quy. Hàm mất mát là trung bình bình phương sai số, chia đôi. Hệ số một phần hai chỉ để khi đạo hàm, số hai triệt tiêu, không đổi nghiệm tối ưu. Chia cho n giúp mất mát là trung bình, so sánh được giữa các cỡ mẫu. Còn bình phương khiến sai số lớn bị phạt nặng.</a:t>
+              <a:t>Hồi quy tuyến tính dự đoán một số thực bằng tổng có trọng số của các đặc trưng cộng hệ số chặn: một đặc trưng là đường thẳng, nhiều đặc trưng là siêu phẳng. Nhóm học w và b bằng cách cực tiểu trung bình bình phương sai số, nhân một phần hai. Bình phương phạt nặng sai số lớn, nên mô hình nhạy với ngoại lai. Chia cho n để mất mát không phụ thuộc cỡ mẫu. Hệ số một phần hai chỉ giúp đạo hàm gọn, không đổi điểm cực tiểu. Dữ liệu là 600 mẫu tổng hợp từ một quan hệ tuyến tính đã biết, nên kiểm tra được kết quả.</a:t>
             </a:r>
             <a:endParaRPr lang="en-US" dirty="0"/>
           </a:p>
@@ -1262,7 +1262,7 @@
           <a:p>
             <a:r>
               <a:rPr lang="en-US" dirty="0"/>
-              <a:t>Đạo hàm theo quy tắc chuỗi: gọi e là phần dư, đạo hàm của e theo trọng số chính là giá trị đặc trưng. Vậy gradient theo trọng số là trung bình của phần dư nhân đặc trưng, gradient theo hệ số chặn là trung bình phần dư. Viết dạng ma trận được công thức ở giữa. Thực nghiệm khởi tạo bằng không, tốc độ học không phẩy ba, dừng khi chuẩn gradient nhỏ hơn mười mũ trừ tám, sau một nghìn một trăm bảy mươi lăm vòng. Nhóm kiểm chứng lại gradient bằng sai phân trung tâm, dung sai mười mũ trừ sáu.</a:t>
+              <a:t>Theo quy tắc chuỗi, gọi e là phần dư. Gradient theo w j là trung bình của e nhân x j, theo b là trung bình của e; dạng ma trận là một phần n nhân X chuyển vị nhân phần dư. Gradient Descent đi ngược hướng gradient một bước eta, cập nhật w và b cùng lúc. Nhóm khởi tạo bằng 0, eta bằng 0.3, dừng khi chuẩn gradient dưới 10 mũ trừ 8, chỉ dựa trên dữ liệu train. Mô hình dừng sau 1175 vòng. Gradient được kiểm chứng bằng sai phân trung tâm, sai khác dưới 10 mũ trừ 6.</a:t>
             </a:r>
             <a:endParaRPr lang="en-US" dirty="0"/>
           </a:p>
@@ -1350,7 +1350,7 @@
           <a:p>
             <a:r>
               <a:rPr lang="en-US" dirty="0"/>
-              <a:t>Hồi quy logistic đưa cùng một điểm tuyến tính qua sigmoid để ra xác suất trong khoảng không đến một. Logit của xác suất là hàm tuyến tính nên biên vẫn là siêu phẳng. Mất mát là cross-entropy, tức âm log hợp lý Bernoulli, phạt rất nặng dự đoán tự tin mà sai. Khi đạo hàm, đạo hàm sigmoid là p nhân một trừ p, triệt tiêu mẫu số của cross-entropy, nên gradient chỉ còn p trừ y, rất gọn. Nhóm dùng tốc độ học không phẩy năm, tối đa năm nghìn vòng, và vòng lặp chạm ngân sách trước khi đạt dung sai.</a:t>
+              <a:t>Logistic đưa cùng điểm tuyến tính z qua hàm sigmoid để ra xác suất từ 0 đến 1. Log odds vẫn tuyến tính, nên biên quyết định tại p bằng 0.5 là một siêu phẳng. Hàm mất mát là cross-entropy, tức âm log-likelihood Bernoulli, phạt rất nặng dự đoán tự tin mà sai. Đạo hàm sigmoid là p nhân một trừ p, triệt tiêu mẫu số của cross-entropy, nên gradient chỉ còn p trừ y, cùng dạng với hồi quy tuyến tính. Nhóm dùng eta 0.5, tối đa 5000 vòng; mô hình chạm giới hạn trước khi đạt dung sai, nên chưa hội tụ chặt.</a:t>
             </a:r>
             <a:endParaRPr lang="en-US" dirty="0"/>
           </a:p>
@@ -1438,7 +1438,7 @@
           <a:p>
             <a:r>
               <a:rPr lang="en-US" dirty="0"/>
-              <a:t>Đây là kết quả chạy thật. Mất mát giảm từ ba mươi phẩy chín xuống không phẩy một hai sáu sau một nghìn một trăm bảy mươi lăm vòng, đơn điệu nên không phân kỳ. Trên một trăm hai mươi mẫu test, các điểm bám sát đường chéo. RMSE không phẩy năm một, đúng bằng độ lệch chuẩn của nhiễu, R bình phương không phẩy chín chín bốn bảy. Trọng số học được rất gần giá trị thật ba, trừ hai, một phẩy năm. Nhưng đây là dữ liệu tổng hợp tuyến tính, nên điểm cao là kỳ vọng, không phải bằng chứng cho dữ liệu thực.</a:t>
+              <a:t>Kết quả hồi quy tuyến tính: mất mát giảm đơn điệu từ 30.9 xuống 0.126, tức tốc độ học phù hợp, không phân kỳ. Trên 120 mẫu test, các điểm bám sát đường chéo. RMSE 0.51, xấp xỉ độ lệch chuẩn của nhiễu là 0.5, nghĩa là phần sai còn lại gần như chỉ là nhiễu. R bình phương 0.995. Trọng số học được 2.99, trừ 2.01 và 1.49, rất gần giá trị thật 3, trừ 2 và 1.5. Nhưng dữ liệu sinh tuyến tính, nên đây chỉ chứng minh cài đặt đúng, chưa nói gì về dữ liệu thực.</a:t>
             </a:r>
             <a:endParaRPr lang="en-US" dirty="0"/>
           </a:p>
@@ -1526,7 +1526,7 @@
           <a:p>
             <a:r>
               <a:rPr lang="en-US" dirty="0"/>
-              <a:t>Với logistic, nhãn sinh ngẫu nhiên nên hai lớp chồng lấn. Cross-entropy giảm từ không phẩy sáu chín ba một, đúng bằng log hai của mô hình đoán ngẫu nhiên, xuống không phẩy bốn năm hai. Trên tập test, mô hình đúng một trăm ba mươi trên một trăm sáu mươi, tức tám mươi mốt phẩy hai lăm phần trăm, F1 lớp dương không phẩy tám năm một, AUC không phẩy tám năm bảy. Các vòng tròn là mẫu phân loại sai, tập trung đúng ở vùng chồng lấn. Phần câu một đến đây là hết, em mời bạn Thành trình bày câu hai.</a:t>
+              <a:t>Với logistic, hai lớp chồng lấn nên không thể tách hoàn hảo. Cross-entropy bắt đầu ở 0.693, đúng bằng log 2 của mô hình đoán 0.5 cho mọi mẫu, rồi giảm xuống 0.45. Trên 160 mẫu test: accuracy 81.25 phần trăm, F1 lớp dương 0.85, AUC 0.86. Accuracy và F1 dùng ngưỡng 0.5, còn AUC tóm tắt mọi ngưỡng. Các vòng tròn là 30 ca sai, nằm ở vùng chồng lấn quanh biên: đó là giới hạn của dữ liệu, không phải lỗi tối ưu. Em xin mời bạn Thành.</a:t>
             </a:r>
             <a:endParaRPr lang="en-US" dirty="0"/>
           </a:p>
@@ -1614,7 +1614,7 @@
           <a:p>
             <a:r>
               <a:rPr lang="en-US" dirty="0"/>
-              <a:t>Dữ liệu là credit-g, mã 31 phiên bản một trên OpenML: một nghìn hồ sơ, hai mươi biến, trong đó bảy biến số và mười ba biến phân loại. Nhãn gồm bảy trăm good và ba trăm bad, nên đây là bài toán mất cân bằng. Một mô hình luôn đoán good đã đạt bảy mươi phần trăm accuracy mà không phát hiện hồ sơ xấu nào, vì vậy nhóm không dùng accuracy làm tiêu chí chính. Kiểm tra dữ liệu sạch: không ô thiếu, không dòng trùng, không giá trị lạ, nên giữ nguyên một nghìn hồ sơ.</a:t>
+              <a:t>Câu hai dùng bộ credit-g, mã 31 trên OpenML: 1000 hồ sơ vay, 20 biến, gồm 7 biến số và 13 biến phân loại. Lớp dương là bad, lớp cần phát hiện. Tỷ lệ 70 trên 30 nên dữ liệu mất cân bằng: luôn đoán good đã đạt 70 phần trăm accuracy mà không bắt được hồ sơ xấu nào. Biểu đồ phải cho thấy số tiền vay lệch phải và hai lớp chồng lấn mạnh. Dữ liệu không có ô thiếu, dòng trùng hay giá trị lạ, nên giữ đủ 1000 hồ sơ; sau min–max và one-hot có 61 đặc trưng.</a:t>
             </a:r>
             <a:endParaRPr lang="en-US" dirty="0"/>
           </a:p>
@@ -1702,7 +1702,7 @@
           <a:p>
             <a:r>
               <a:rPr lang="en-US" dirty="0"/>
-              <a:t>Điểm nhóm muốn nhấn mạnh là quy trình. Tập test tách ngay từ đầu và chỉ dùng một lần, sau khi mọi lựa chọn xong. Trong tám trăm hồ sơ development, nhóm chạy năm fold phân tầng, và chuẩn hóa nằm trong pipeline nên mỗi fold chỉ học min–max từ train của chính nó. Nếu chuẩn hóa trước rồi mới chia fold thì thông tin validation đã rò rỉ và điểm sẽ đẹp giả tạo. Tiêu chí chọn là macro F1 vì cho hai lớp trọng số ngang nhau.</a:t>
+              <a:t>Điểm nhóm chú trọng nhất là chống rò rỉ dữ liệu. Một, tách 200 hồ sơ test phân tầng ngay từ đầu. Hai, chuẩn hóa và one-hot nằm trong pipeline, nên mỗi fold chỉ học min, max và danh mục từ phần train của fold đó. Nếu chuẩn hóa trước rồi mới chia, thông tin validation đã lọt vào train và điểm sẽ đẹp giả tạo. Ba, mọi mô hình dùng chung năm fold phân tầng, chọn theo macro F1. Bốn, chốt xong mọi lựa chọn mới chạy test, đúng một lần.</a:t>
             </a:r>
             <a:endParaRPr lang="en-US" dirty="0"/>
           </a:p>
@@ -1800,7 +1800,7 @@
       </p:grpSpPr>
       <p:pic>
         <p:nvPicPr>
-          <p:cNvPr id="2" name="Image 0" descr="/home/towfienes/TDTU/ML/MidTerm/report/assets/tdtu-logo.png">    </p:cNvPr>
+          <p:cNvPr id="2" name="Image 0" descr="Logo Đại học Tôn Đức Thắng">    </p:cNvPr>
           <p:cNvPicPr>
             <a:picLocks noChangeAspect="1"/>
           </p:cNvPicPr>
@@ -1963,7 +1963,7 @@
       </p:grpSpPr>
       <p:pic>
         <p:nvPicPr>
-          <p:cNvPr id="2" name="Image 0" descr="/home/towfienes/TDTU/ML/MidTerm/report/assets/tdtu-logo.png">    </p:cNvPr>
+          <p:cNvPr id="2" name="Image 0" descr="Logo Đại học Tôn Đức Thắng">    </p:cNvPr>
           <p:cNvPicPr>
             <a:picLocks noChangeAspect="1"/>
           </p:cNvPicPr>
@@ -2879,7 +2879,7 @@
       </p:sp>
       <p:pic>
         <p:nvPicPr>
-          <p:cNvPr id="4" name="Image 0" descr="/home/towfienes/TDTU/ML/MidTerm/presentation/figures/fig_q2_cv.png">    </p:cNvPr>
+          <p:cNvPr id="4" name="Image 0" descr="fig_q2_cv.png">    </p:cNvPr>
           <p:cNvPicPr>
             <a:picLocks noChangeAspect="1"/>
           </p:cNvPicPr>
@@ -6172,7 +6172,7 @@
                 <a:ea typeface="Arial" pitchFamily="34" charset="-122"/>
                 <a:cs typeface="Arial" pitchFamily="34" charset="-120"/>
               </a:rPr>
-              <a:t>16 mô hình đều vượt baseline</a:t>
+              <a:t>14 mô hình đều vượt baseline</a:t>
             </a:r>
             <a:endParaRPr lang="en-US" sz="1600" dirty="0"/>
           </a:p>
@@ -6355,7 +6355,7 @@
       </p:sp>
       <p:pic>
         <p:nvPicPr>
-          <p:cNvPr id="4" name="Image 0" descr="/home/towfienes/TDTU/ML/MidTerm/presentation/figures/fig_q2_test.png">    </p:cNvPr>
+          <p:cNvPr id="4" name="Image 0" descr="fig_q2_test.png">    </p:cNvPr>
           <p:cNvPicPr>
             <a:picLocks noChangeAspect="1"/>
           </p:cNvPicPr>
@@ -6739,7 +6739,7 @@
       </p:sp>
       <p:pic>
         <p:nvPicPr>
-          <p:cNvPr id="4" name="Image 0" descr="/home/towfienes/TDTU/ML/MidTerm/presentation/figures/fig_overfit.png">    </p:cNvPr>
+          <p:cNvPr id="4" name="Image 0" descr="fig_overfit.png">    </p:cNvPr>
           <p:cNvPicPr>
             <a:picLocks noChangeAspect="1"/>
           </p:cNvPicPr>
@@ -12011,7 +12011,7 @@
       </p:sp>
       <p:pic>
         <p:nvPicPr>
-          <p:cNvPr id="4" name="Image 0" descr="/home/towfienes/TDTU/ML/MidTerm/presentation/figures/fig_q1_linear.png">    </p:cNvPr>
+          <p:cNvPr id="4" name="Image 0" descr="fig_q1_linear.png">    </p:cNvPr>
           <p:cNvPicPr>
             <a:picLocks noChangeAspect="1"/>
           </p:cNvPicPr>
@@ -12498,7 +12498,7 @@
       </p:sp>
       <p:pic>
         <p:nvPicPr>
-          <p:cNvPr id="4" name="Image 0" descr="/home/towfienes/TDTU/ML/MidTerm/presentation/figures/fig_q1_logistic.png">    </p:cNvPr>
+          <p:cNvPr id="4" name="Image 0" descr="fig_q1_logistic.png">    </p:cNvPr>
           <p:cNvPicPr>
             <a:picLocks noChangeAspect="1"/>
           </p:cNvPicPr>
@@ -13089,7 +13089,7 @@
       </p:sp>
       <p:pic>
         <p:nvPicPr>
-          <p:cNvPr id="4" name="Image 0" descr="/home/towfienes/TDTU/ML/MidTerm/presentation/figures/fig_q2_eda.png">    </p:cNvPr>
+          <p:cNvPr id="4" name="Image 0" descr="fig_q2_eda.png">    </p:cNvPr>
           <p:cNvPicPr>
             <a:picLocks noChangeAspect="1"/>
           </p:cNvPicPr>

</xml_diff>

<commit_message>
ML midterm talk: speaker-neutral script so one person can present alone
- Scripts no longer name who speaks; slide 2 describes the three parts by
  content, and the slide 7/11 hand-offs move to an optional 'handoff' field.
- TRANSCRIPT.md and the PPTX speaker notes are rebuilt from the same source
  (1341 words, about 8:56); the transcript notes that everyone should
  rehearse all 14 slides.
- Study viewer: a Group / Solo toggle hides speaker names and hand-off
  lines, the slide list groups by part, and thumbnails keep their 16:9
  ratio.

Co-Authored-By: Claude Opus 5.5 <noreply@anthropic.com>
Claude-Session: https://claude.ai/code/session_01SizuVJfQhxREw1pyh2WW9i
</commit_message>
<xml_diff>
--- a/ML/MidTerm/presentation/midterm_presentation.pptx
+++ b/ML/MidTerm/presentation/midterm_presentation.pptx
@@ -120,13 +120,13 @@
   <p:extLst>
     <p:ext uri="{521415D9-36F7-43E2-AB2F-B90AF26B5E84}">
       <p14:sectionLst xmlns:p14="http://schemas.microsoft.com/office/powerpoint/2010/main">
-        <p14:section name="Mở đầu" id="{94ebbb47-9d04-da12-7341-a44b16edc5ca}">
+        <p14:section name="Mở đầu" id="{8d86ab0b-c530-18eb-5663-e11fd105df07}">
           <p14:sldIdLst>
             <p14:sldId id="256"/>
             <p14:sldId id="257"/>
           </p14:sldIdLst>
         </p14:section>
-        <p14:section name="Câu 1" id="{fc5aece1-70a3-6463-ef21-1c9d9bd7b74f}">
+        <p14:section name="Câu 1" id="{5fba37f3-ba67-a891-7805-0f90f161d238}">
           <p14:sldIdLst>
             <p14:sldId id="258"/>
             <p14:sldId id="259"/>
@@ -135,7 +135,7 @@
             <p14:sldId id="262"/>
           </p14:sldIdLst>
         </p14:section>
-        <p14:section name="Câu 2" id="{b3fa28b6-a386-8b32-f6af-8c789898364b}">
+        <p14:section name="Câu 2" id="{2761904d-73c2-53f0-c48e-902334e5bbff}">
           <p14:sldIdLst>
             <p14:sldId id="263"/>
             <p14:sldId id="264"/>
@@ -144,12 +144,12 @@
             <p14:sldId id="267"/>
           </p14:sldIdLst>
         </p14:section>
-        <p14:section name="Overfitting" id="{ae99d017-e920-3199-1435-cbafcfbc532f}">
+        <p14:section name="Overfitting" id="{20b9c704-efcb-e43f-682e-07446b6a9489}">
           <p14:sldIdLst>
             <p14:sldId id="268"/>
           </p14:sldIdLst>
         </p14:section>
-        <p14:section name="Kết luận" id="{0a9b51ab-ef25-8d76-91a4-7a7621cfcbe3}">
+        <p14:section name="Kết luận" id="{d85f6a08-06b1-16d5-4262-18282e8847c9}">
           <p14:sldIdLst>
             <p14:sldId id="269"/>
           </p14:sldIdLst>
@@ -734,7 +734,7 @@
           <a:p>
             <a:r>
               <a:rPr lang="en-US" dirty="0"/>
-              <a:t>Đánh giá độc lập là 200 hồ sơ test. MLP đạt accuracy 0.79, macro F1 0.73, AUC 0.81. Đáng chú ý, logistic tự cài đặt từ câu một cũng đạt macro F1 0.730, gần như bằng MLP: trên một bảng dữ liệu nhỏ, mô hình phức tạp hơn không mang lại lợi ích rõ ràng. Cả 14 mô hình đều vượt baseline về macro F1, nhưng nhóm dẫn đầu chỉ chênh nhau vài phần nghìn, nên không nên đọc bảng này như bảng xếp hạng. Em xin mời bạn Tâm.</a:t>
+              <a:t>Đánh giá độc lập là 200 hồ sơ test. MLP đạt accuracy 0.79, macro F1 0.73, AUC 0.81. Đáng chú ý, logistic tự cài đặt từ câu một cũng đạt macro F1 0.730, gần như bằng MLP: trên một bảng dữ liệu nhỏ, mô hình phức tạp hơn không mang lại lợi ích rõ ràng. Cả 14 mô hình đều vượt baseline về macro F1, nhưng nhóm dẫn đầu chỉ chênh nhau vài phần nghìn, nên không nên đọc bảng này như bảng xếp hạng. Tiếp theo, ta đọc kỹ hơn con số accuracy này.</a:t>
             </a:r>
             <a:endParaRPr lang="en-US" dirty="0"/>
           </a:p>
@@ -1086,7 +1086,7 @@
           <a:p>
             <a:r>
               <a:rPr lang="en-US" dirty="0"/>
-              <a:t>Bài gồm ba phần. Em trình bày câu một: mô hình, hàm mất mát, gradient và kết quả. Bạn Thành trình bày dữ liệu, quy trình và cách chọn mô hình ở câu hai. Bạn Tâm trình bày cách đọc kết quả, overfitting và kết luận. Câu hỏi xuyên suốt là: mô hình học được gì, và làm sao biết nó tổng quát hóa sang dữ liệu mới?</a:t>
+              <a:t>Bài gồm ba phần. Câu một tự cài đặt hai mô hình hồi quy, từ hàm mất mát, gradient đến kết quả. Câu hai đi từ dữ liệu credit-g, quy trình chống rò rỉ đến cách chọn mô hình. Phần cuối là đọc kết quả, overfitting và kết luận. Câu hỏi xuyên suốt là: mô hình học được gì, và làm sao biết nó tổng quát hóa sang dữ liệu mới?</a:t>
             </a:r>
             <a:endParaRPr lang="en-US" dirty="0"/>
           </a:p>
@@ -1526,7 +1526,7 @@
           <a:p>
             <a:r>
               <a:rPr lang="en-US" dirty="0"/>
-              <a:t>Với logistic, hai lớp chồng lấn nên không thể tách hoàn hảo. Cross-entropy bắt đầu ở 0.693, đúng bằng log 2 của mô hình đoán 0.5 cho mọi mẫu, rồi giảm xuống 0.45. Trên 160 mẫu test: accuracy 81.25 phần trăm, F1 lớp dương 0.85, AUC 0.86. Accuracy và F1 dùng ngưỡng 0.5, còn AUC tóm tắt mọi ngưỡng. Các vòng tròn là 30 ca sai, nằm ở vùng chồng lấn quanh biên: đó là giới hạn của dữ liệu, không phải lỗi tối ưu. Em xin mời bạn Thành.</a:t>
+              <a:t>Với logistic, hai lớp chồng lấn nên không thể tách hoàn hảo. Cross-entropy bắt đầu ở 0.693, đúng bằng log 2 của mô hình đoán 0.5 cho mọi mẫu, rồi giảm xuống 0.45. Trên 160 mẫu test: accuracy 81.25 phần trăm, F1 lớp dương 0.85, AUC 0.86. Accuracy và F1 dùng ngưỡng 0.5, còn AUC tóm tắt mọi ngưỡng. Các vòng tròn là 30 ca sai, nằm ở vùng chồng lấn quanh biên: đó là giới hạn của dữ liệu, không phải lỗi tối ưu. Tiếp theo là câu hai, trên dữ liệu thật.</a:t>
             </a:r>
             <a:endParaRPr lang="en-US" dirty="0"/>
           </a:p>

</xml_diff>